<commit_message>
Demo 8 reviewer round 2 — three blockers fixed
Slide 3 (Frédérich K=0.10 recap): add explicit "landmark, not a target —
your per-variable Ks won't hit 0.10" line so students don't leave the slide
thinking 0.10 is what their bars need to match.

Slide 13 (color vs ecology K): rewrite right rail from "ecology bars above
color bars = color evolves faster than the niche it tracks" (which the
walkthrough data doesn't actually show — too few species) to "watch for
this in your own family — Chaetodontidae is too small to see it sharply."

TA Guide §2.8: promote the matching caveat from a buried "takeaway" to a
callout-important block at the top of the section, so the lecturer cues
themselves the same way when slide 13 lands.

Co-Authored-By: Claude Opus 4.7 (1M context) <noreply@anthropic.com>
</commit_message>
<xml_diff>
--- a/demo8/slides/demo8-intro-slides.pptx
+++ b/demo8/slides/demo8-intro-slides.pptx
@@ -4370,8 +4370,8 @@
         </p:nvSpPr>
         <p:spPr>
           <a:xfrm>
-            <a:off x="9052560" y="1828800"/>
-            <a:ext cx="2926080" cy="4389120"/>
+            <a:off x="9052560" y="1691640"/>
+            <a:ext cx="2926080" cy="4572000"/>
           </a:xfrm>
           <a:prstGeom prst="rect">
             <a:avLst/>
@@ -4388,7 +4388,7 @@
               <a:spcAft>
                 <a:spcPts val="880"/>
               </a:spcAft>
-              <a:defRPr sz="1800">
+              <a:defRPr sz="1700">
                 <a:solidFill>
                   <a:srgbClr val="C4C6D0"/>
                 </a:solidFill>
@@ -4404,7 +4404,7 @@
               <a:spcAft>
                 <a:spcPts val="880"/>
               </a:spcAft>
-              <a:defRPr sz="1800">
+              <a:defRPr sz="1700">
                 <a:solidFill>
                   <a:srgbClr val="C4C6D0"/>
                 </a:solidFill>
@@ -4412,7 +4412,7 @@
               </a:defRPr>
             </a:pPr>
             <a:r>
-              <a:t>K = 1, the</a:t>
+              <a:t>K = 1, BM</a:t>
             </a:r>
           </a:p>
           <a:p>
@@ -4420,7 +4420,7 @@
               <a:spcAft>
                 <a:spcPts val="880"/>
               </a:spcAft>
-              <a:defRPr sz="1800">
+              <a:defRPr sz="1700">
                 <a:solidFill>
                   <a:srgbClr val="C4C6D0"/>
                 </a:solidFill>
@@ -4428,7 +4428,7 @@
               </a:defRPr>
             </a:pPr>
             <a:r>
-              <a:t>BM expectation.</a:t>
+              <a:t>expectation.</a:t>
             </a:r>
           </a:p>
           <a:p>
@@ -4436,7 +4436,7 @@
               <a:spcAft>
                 <a:spcPts val="880"/>
               </a:spcAft>
-              <a:defRPr sz="1800">
+              <a:defRPr sz="1700">
                 <a:solidFill>
                   <a:srgbClr val="C4C6D0"/>
                 </a:solidFill>
@@ -4449,7 +4449,7 @@
               <a:spcAft>
                 <a:spcPts val="880"/>
               </a:spcAft>
-              <a:defRPr sz="1800">
+              <a:defRPr sz="1700">
                 <a:solidFill>
                   <a:srgbClr val="C4C6D0"/>
                 </a:solidFill>
@@ -4457,7 +4457,7 @@
               </a:defRPr>
             </a:pPr>
             <a:r>
-              <a:t>Ecology bars</a:t>
+              <a:t>Watch for</a:t>
             </a:r>
           </a:p>
           <a:p>
@@ -4465,7 +4465,7 @@
               <a:spcAft>
                 <a:spcPts val="880"/>
               </a:spcAft>
-              <a:defRPr sz="1800">
+              <a:defRPr sz="1700">
                 <a:solidFill>
                   <a:srgbClr val="C4C6D0"/>
                 </a:solidFill>
@@ -4473,7 +4473,7 @@
               </a:defRPr>
             </a:pPr>
             <a:r>
-              <a:t>above color bars</a:t>
+              <a:t>ecology bars</a:t>
             </a:r>
           </a:p>
           <a:p>
@@ -4481,7 +4481,7 @@
               <a:spcAft>
                 <a:spcPts val="880"/>
               </a:spcAft>
-              <a:defRPr sz="1800">
+              <a:defRPr sz="1700">
                 <a:solidFill>
                   <a:srgbClr val="C4C6D0"/>
                 </a:solidFill>
@@ -4489,7 +4489,7 @@
               </a:defRPr>
             </a:pPr>
             <a:r>
-              <a:t>= color evolves</a:t>
+              <a:t>above color</a:t>
             </a:r>
           </a:p>
           <a:p>
@@ -4497,7 +4497,7 @@
               <a:spcAft>
                 <a:spcPts val="880"/>
               </a:spcAft>
-              <a:defRPr sz="1800">
+              <a:defRPr sz="1700">
                 <a:solidFill>
                   <a:srgbClr val="C4C6D0"/>
                 </a:solidFill>
@@ -4505,7 +4505,7 @@
               </a:defRPr>
             </a:pPr>
             <a:r>
-              <a:t>faster than the</a:t>
+              <a:t>bars in your</a:t>
             </a:r>
           </a:p>
           <a:p>
@@ -4513,7 +4513,7 @@
               <a:spcAft>
                 <a:spcPts val="880"/>
               </a:spcAft>
-              <a:defRPr sz="1800">
+              <a:defRPr sz="1700">
                 <a:solidFill>
                   <a:srgbClr val="C4C6D0"/>
                 </a:solidFill>
@@ -4521,7 +4521,55 @@
               </a:defRPr>
             </a:pPr>
             <a:r>
-              <a:t>niche it tracks.</a:t>
+              <a:t>own family —</a:t>
+            </a:r>
+          </a:p>
+          <a:p>
+            <a:pPr algn="l">
+              <a:spcAft>
+                <a:spcPts val="880"/>
+              </a:spcAft>
+              <a:defRPr sz="1700">
+                <a:solidFill>
+                  <a:srgbClr val="C4C6D0"/>
+                </a:solidFill>
+                <a:latin typeface="Aptos"/>
+              </a:defRPr>
+            </a:pPr>
+            <a:r>
+              <a:t>Chaetodontidae</a:t>
+            </a:r>
+          </a:p>
+          <a:p>
+            <a:pPr algn="l">
+              <a:spcAft>
+                <a:spcPts val="880"/>
+              </a:spcAft>
+              <a:defRPr sz="1700">
+                <a:solidFill>
+                  <a:srgbClr val="C4C6D0"/>
+                </a:solidFill>
+                <a:latin typeface="Aptos"/>
+              </a:defRPr>
+            </a:pPr>
+            <a:r>
+              <a:t>is too small to</a:t>
+            </a:r>
+          </a:p>
+          <a:p>
+            <a:pPr algn="l">
+              <a:spcAft>
+                <a:spcPts val="880"/>
+              </a:spcAft>
+              <a:defRPr sz="1700">
+                <a:solidFill>
+                  <a:srgbClr val="C4C6D0"/>
+                </a:solidFill>
+                <a:latin typeface="Aptos"/>
+              </a:defRPr>
+            </a:pPr>
+            <a:r>
+              <a:t>see it sharply.</a:t>
             </a:r>
           </a:p>
         </p:txBody>
@@ -6778,8 +6826,8 @@
         </p:nvSpPr>
         <p:spPr>
           <a:xfrm>
-            <a:off x="640080" y="2194560"/>
-            <a:ext cx="10972800" cy="1645920"/>
+            <a:off x="640080" y="2011680"/>
+            <a:ext cx="10972800" cy="1463040"/>
           </a:xfrm>
           <a:prstGeom prst="rect">
             <a:avLst/>
@@ -6794,7 +6842,7 @@
           <a:p>
             <a:pPr algn="ctr"/>
             <a:r>
-              <a:rPr sz="14000" b="1" i="0">
+              <a:rPr sz="13000" b="1" i="0">
                 <a:solidFill>
                   <a:srgbClr val="D4A853"/>
                 </a:solidFill>
@@ -6813,7 +6861,7 @@
         </p:nvSpPr>
         <p:spPr>
           <a:xfrm>
-            <a:off x="640080" y="4206240"/>
+            <a:off x="640080" y="3840480"/>
             <a:ext cx="10972800" cy="365760"/>
           </a:xfrm>
           <a:prstGeom prst="rect">
@@ -6835,7 +6883,7 @@
                 </a:solidFill>
                 <a:latin typeface="Aptos"/>
               </a:rPr>
-              <a:t>Chaetodontidae · multivariate Blomberg's K · 30 binary pattern motifs</a:t>
+              <a:t>Chaetodontidae · multivariate Blomberg's K · 30 binary motifs</a:t>
             </a:r>
           </a:p>
         </p:txBody>
@@ -6848,8 +6896,8 @@
         </p:nvSpPr>
         <p:spPr>
           <a:xfrm>
-            <a:off x="1828800" y="4846320"/>
-            <a:ext cx="8686800" cy="1188720"/>
+            <a:off x="1828800" y="4526280"/>
+            <a:ext cx="8686800" cy="868680"/>
           </a:xfrm>
           <a:prstGeom prst="rect">
             <a:avLst/>
@@ -6890,23 +6938,7 @@
               </a:defRPr>
             </a:pPr>
             <a:r>
-              <a:t>Convergence and reversal across the tree.</a:t>
-            </a:r>
-          </a:p>
-          <a:p>
-            <a:pPr algn="ctr">
-              <a:spcAft>
-                <a:spcPts val="880"/>
-              </a:spcAft>
-              <a:defRPr sz="1800">
-                <a:solidFill>
-                  <a:srgbClr val="F6F6F8"/>
-                </a:solidFill>
-                <a:latin typeface="Aptos"/>
-              </a:defRPr>
-            </a:pPr>
-            <a:r>
-              <a:t>Phylogeny barely predicts the next species' pattern.</a:t>
+              <a:t>Convergent across the tree.</a:t>
             </a:r>
           </a:p>
         </p:txBody>
@@ -6914,6 +6946,41 @@
       <p:sp>
         <p:nvSpPr>
           <p:cNvPr id="8" name="TextBox 7"/>
+          <p:cNvSpPr txBox="1"/>
+          <p:nvPr/>
+        </p:nvSpPr>
+        <p:spPr>
+          <a:xfrm>
+            <a:off x="640080" y="5715000"/>
+            <a:ext cx="10972800" cy="411480"/>
+          </a:xfrm>
+          <a:prstGeom prst="rect">
+            <a:avLst/>
+          </a:prstGeom>
+          <a:noFill/>
+        </p:spPr>
+        <p:txBody>
+          <a:bodyPr wrap="square" anchor="t">
+            <a:spAutoFit/>
+          </a:bodyPr>
+          <a:lstStyle/>
+          <a:p>
+            <a:pPr algn="ctr"/>
+            <a:r>
+              <a:rPr sz="2000" b="0" i="1">
+                <a:solidFill>
+                  <a:srgbClr val="E07A5F"/>
+                </a:solidFill>
+                <a:latin typeface="Aptos"/>
+              </a:rPr>
+              <a:t>A landmark — not a target. Your per-variable Ks won't hit 0.10.</a:t>
+            </a:r>
+          </a:p>
+        </p:txBody>
+      </p:sp>
+      <p:sp>
+        <p:nvSpPr>
+          <p:cNvPr id="9" name="TextBox 8"/>
           <p:cNvSpPr txBox="1"/>
           <p:nvPr/>
         </p:nvSpPr>

</xml_diff>

<commit_message>
Demo 8 writeup: split prompt for Frederich-covered vs Labrid/Balistoid groups
Four of the seven student groups are within Labridae (Scarinae,
Cirrhilabrini, Hypsigenyinae, Halichoerine) and one is in Balistoidea —
families Frederich et al. 2026 did not score. Asking those groups to
"compare to Frederich's surgeonfish result" is a forced comparison.

The §3 "Take it home" writeup prompt now branches:
- Acanthuridae and Pomacanthidae groups: compare per-variable K to
  Frederich's published multivariate K for their family.
- Labrid + Balistoid groups: their per-variable K values are the first
  reported for their clade. Prompt asks them to describe + predict
  which variable carries the signal in their family, vs the Chaetodon
  walkthrough where A was the conserved one.

Co-Authored-By: Claude Opus 4.7 (1M context) <noreply@anthropic.com>
</commit_message>
<xml_diff>
--- a/demo8/slides/demo8-intro-slides.pptx
+++ b/demo8/slides/demo8-intro-slides.pptx
@@ -3723,7 +3723,7 @@
                 </a:solidFill>
                 <a:latin typeface="Aptos"/>
               </a:rPr>
-              <a:t>p_4 and m_c dropped because the trait covariance is rank-deficient</a:t>
+              <a:t>same 6 variables · centering uses the tree's BM variance-covariance</a:t>
             </a:r>
           </a:p>
         </p:txBody>
@@ -7735,7 +7735,7 @@
                 </a:solidFill>
                 <a:latin typeface="Aptos"/>
               </a:rPr>
-              <a:t>9 pattern stats per species · pavo classify() + adjacent()</a:t>
+              <a:t>6 pattern stats per species · pavo classify() + adjacent()</a:t>
             </a:r>
           </a:p>
         </p:txBody>
@@ -7844,7 +7844,7 @@
               </a:defRPr>
             </a:pPr>
             <a:r>
-              <a:t>Watch for tight scatter:</a:t>
+              <a:t>Six full-rank descriptors:</a:t>
             </a:r>
           </a:p>
           <a:p>
@@ -7860,7 +7860,7 @@
               </a:defRPr>
             </a:pPr>
             <a:r>
-              <a:t>m, m_r, m_c all carry</a:t>
+              <a:t>m, A, Jc, Jt, m_dS, m_dL.</a:t>
             </a:r>
           </a:p>
           <a:p>
@@ -7875,8 +7875,53 @@
                 <a:latin typeface="Aptos"/>
               </a:defRPr>
             </a:pPr>
-            <a:r>
-              <a:t>the same information.</a:t>
+          </a:p>
+          <a:p>
+            <a:pPr algn="l">
+              <a:spcAft>
+                <a:spcPts val="880"/>
+              </a:spcAft>
+              <a:defRPr sz="1800">
+                <a:solidFill>
+                  <a:srgbClr val="C4C6D0"/>
+                </a:solidFill>
+                <a:latin typeface="Aptos"/>
+              </a:defRPr>
+            </a:pPr>
+            <a:r>
+              <a:t>Watch for tight scatter:</a:t>
+            </a:r>
+          </a:p>
+          <a:p>
+            <a:pPr algn="l">
+              <a:spcAft>
+                <a:spcPts val="880"/>
+              </a:spcAft>
+              <a:defRPr sz="1800">
+                <a:solidFill>
+                  <a:srgbClr val="C4C6D0"/>
+                </a:solidFill>
+                <a:latin typeface="Aptos"/>
+              </a:defRPr>
+            </a:pPr>
+            <a:r>
+              <a:t>redundant axes → fewer</a:t>
+            </a:r>
+          </a:p>
+          <a:p>
+            <a:pPr algn="l">
+              <a:spcAft>
+                <a:spcPts val="880"/>
+              </a:spcAft>
+              <a:defRPr sz="1800">
+                <a:solidFill>
+                  <a:srgbClr val="C4C6D0"/>
+                </a:solidFill>
+                <a:latin typeface="Aptos"/>
+              </a:defRPr>
+            </a:pPr>
+            <a:r>
+              <a:t>real pattern dimensions.</a:t>
             </a:r>
           </a:p>
         </p:txBody>

</xml_diff>